<commit_message>
docs: standardize role title to Azure Data Engineer
</commit_message>
<xml_diff>
--- a/applications/ey-gds-azure-data-engineer-2026-10-12-4477576256-packet/dedeepya-EY-Azure-Data-Engineer-4477576256-pitch.pptx
+++ b/applications/ey-gds-azure-data-engineer-2026-10-12-4477576256-packet/dedeepya-EY-Azure-Data-Engineer-4477576256-pitch.pptx
@@ -3146,7 +3146,7 @@
         </p:nvSpPr>
         <p:spPr>
           <a:xfrm>
-            <a:off x="0" y="5303520"/>
+            <a:off x="0" y="5120640"/>
             <a:ext cx="12191695" cy="73152"/>
           </a:xfrm>
           <a:prstGeom prst="rect">
@@ -3189,8 +3189,8 @@
         </p:nvSpPr>
         <p:spPr>
           <a:xfrm>
-            <a:off x="731520" y="914400"/>
-            <a:ext cx="7589520" cy="685800"/>
+            <a:off x="731520" y="1097280"/>
+            <a:ext cx="10515600" cy="731520"/>
           </a:xfrm>
           <a:prstGeom prst="rect">
             <a:avLst/>
@@ -3204,7 +3204,7 @@
           <a:lstStyle/>
           <a:p>
             <a:pPr>
-              <a:defRPr sz="4000" b="1">
+              <a:defRPr sz="4200" b="1">
                 <a:solidFill>
                   <a:srgbClr val="FFFFFF"/>
                 </a:solidFill>
@@ -3225,8 +3225,8 @@
         </p:nvSpPr>
         <p:spPr>
           <a:xfrm>
-            <a:off x="731520" y="1645920"/>
-            <a:ext cx="7589520" cy="594360"/>
+            <a:off x="731520" y="2011680"/>
+            <a:ext cx="10515600" cy="548640"/>
           </a:xfrm>
           <a:prstGeom prst="rect">
             <a:avLst/>
@@ -3240,7 +3240,7 @@
           <a:lstStyle/>
           <a:p>
             <a:pPr>
-              <a:defRPr sz="1800" b="1">
+              <a:defRPr sz="2200" b="1">
                 <a:solidFill>
                   <a:srgbClr val="FBBF24"/>
                 </a:solidFill>
@@ -3248,7 +3248,7 @@
               </a:defRPr>
             </a:pPr>
             <a:r>
-              <a:t>Azure Data Engineer &amp; Lakehouse Specialist  |  Azure Data Engineer (Staff)</a:t>
+              <a:t>Azure Data Engineer &amp; Lakehouse Specialist  |  Azure Data Engineer</a:t>
             </a:r>
           </a:p>
         </p:txBody>
@@ -3261,8 +3261,8 @@
         </p:nvSpPr>
         <p:spPr>
           <a:xfrm>
-            <a:off x="731520" y="2331720"/>
-            <a:ext cx="7589520" cy="411480"/>
+            <a:off x="731520" y="2651760"/>
+            <a:ext cx="10515600" cy="365760"/>
           </a:xfrm>
           <a:prstGeom prst="rect">
             <a:avLst/>
@@ -3276,7 +3276,7 @@
           <a:lstStyle/>
           <a:p>
             <a:pPr>
-              <a:defRPr sz="1300">
+              <a:defRPr sz="1400">
                 <a:solidFill>
                   <a:srgbClr val="CBD5E1"/>
                 </a:solidFill>
@@ -3297,8 +3297,8 @@
         </p:nvSpPr>
         <p:spPr>
           <a:xfrm>
-            <a:off x="731520" y="2880360"/>
-            <a:ext cx="7589520" cy="2194560"/>
+            <a:off x="731520" y="3291840"/>
+            <a:ext cx="10515600" cy="1645920"/>
           </a:xfrm>
           <a:prstGeom prst="rect">
             <a:avLst/>
@@ -3313,11 +3313,11 @@
           <a:p>
             <a:pPr>
               <a:spcAft>
-                <a:spcPts val="700"/>
+                <a:spcPts val="600"/>
               </a:spcAft>
             </a:pPr>
             <a:r>
-              <a:rPr b="1" sz="1300">
+              <a:rPr b="1" sz="1350">
                 <a:solidFill>
                   <a:srgbClr val="F59E0B"/>
                 </a:solidFill>
@@ -3326,7 +3326,7 @@
               <a:t>•  </a:t>
             </a:r>
             <a:r>
-              <a:rPr b="1" sz="1300">
+              <a:rPr b="1" sz="1350">
                 <a:solidFill>
                   <a:srgbClr val="FFFFFF"/>
                 </a:solidFill>
@@ -3335,7 +3335,7 @@
               <a:t>Associate - Data Engineer @ Cognizant: </a:t>
             </a:r>
             <a:r>
-              <a:rPr b="0" sz="1300">
+              <a:rPr b="0" sz="1350">
                 <a:solidFill>
                   <a:srgbClr val="CBD5E1"/>
                 </a:solidFill>
@@ -3347,11 +3347,11 @@
           <a:p>
             <a:pPr>
               <a:spcAft>
-                <a:spcPts val="700"/>
+                <a:spcPts val="600"/>
               </a:spcAft>
             </a:pPr>
             <a:r>
-              <a:rPr b="1" sz="1300">
+              <a:rPr b="1" sz="1350">
                 <a:solidFill>
                   <a:srgbClr val="F59E0B"/>
                 </a:solidFill>
@@ -3360,7 +3360,7 @@
               <a:t>•  </a:t>
             </a:r>
             <a:r>
-              <a:rPr b="1" sz="1300">
+              <a:rPr b="1" sz="1350">
                 <a:solidFill>
                   <a:srgbClr val="FFFFFF"/>
                 </a:solidFill>
@@ -3369,7 +3369,7 @@
               <a:t>Databricks Certified Associate: </a:t>
             </a:r>
             <a:r>
-              <a:rPr b="0" sz="1300">
+              <a:rPr b="0" sz="1350">
                 <a:solidFill>
                   <a:srgbClr val="CBD5E1"/>
                 </a:solidFill>
@@ -3381,11 +3381,11 @@
           <a:p>
             <a:pPr>
               <a:spcAft>
-                <a:spcPts val="700"/>
+                <a:spcPts val="600"/>
               </a:spcAft>
             </a:pPr>
             <a:r>
-              <a:rPr b="1" sz="1300">
+              <a:rPr b="1" sz="1350">
                 <a:solidFill>
                   <a:srgbClr val="F59E0B"/>
                 </a:solidFill>
@@ -3394,7 +3394,7 @@
               <a:t>•  </a:t>
             </a:r>
             <a:r>
-              <a:rPr b="1" sz="1300">
+              <a:rPr b="1" sz="1350">
                 <a:solidFill>
                   <a:srgbClr val="FFFFFF"/>
                 </a:solidFill>
@@ -3403,7 +3403,7 @@
               <a:t>Microsoft Certified PL-300: </a:t>
             </a:r>
             <a:r>
-              <a:rPr b="0" sz="1300">
+              <a:rPr b="0" sz="1350">
                 <a:solidFill>
                   <a:srgbClr val="CBD5E1"/>
                 </a:solidFill>
@@ -3415,11 +3415,11 @@
           <a:p>
             <a:pPr>
               <a:spcAft>
-                <a:spcPts val="700"/>
+                <a:spcPts val="600"/>
               </a:spcAft>
             </a:pPr>
             <a:r>
-              <a:rPr b="1" sz="1300">
+              <a:rPr b="1" sz="1350">
                 <a:solidFill>
                   <a:srgbClr val="F59E0B"/>
                 </a:solidFill>
@@ -3428,7 +3428,7 @@
               <a:t>•  </a:t>
             </a:r>
             <a:r>
-              <a:rPr b="1" sz="1300">
+              <a:rPr b="1" sz="1350">
                 <a:solidFill>
                   <a:srgbClr val="FFFFFF"/>
                 </a:solidFill>
@@ -3437,7 +3437,7 @@
               <a:t>Immediate Availability: </a:t>
             </a:r>
             <a:r>
-              <a:rPr b="0" sz="1300">
+              <a:rPr b="0" sz="1350">
                 <a:solidFill>
                   <a:srgbClr val="CBD5E1"/>
                 </a:solidFill>
@@ -3448,95 +3448,16 @@
           </a:p>
         </p:txBody>
       </p:sp>
-      <p:pic>
-        <p:nvPicPr>
-          <p:cNvPr id="8" name="Picture 7" descr="dedeepya_headshot_rounded.png"/>
-          <p:cNvPicPr>
-            <a:picLocks noChangeAspect="1"/>
-          </p:cNvPicPr>
-          <p:nvPr/>
-        </p:nvPicPr>
-        <p:blipFill>
-          <a:blip r:embed="rId2"/>
-          <a:stretch>
-            <a:fillRect/>
-          </a:stretch>
-        </p:blipFill>
-        <p:spPr>
-          <a:xfrm>
-            <a:off x="8595360" y="1051560"/>
-            <a:ext cx="2926080" cy="2926080"/>
-          </a:xfrm>
-          <a:prstGeom prst="rect">
-            <a:avLst/>
-          </a:prstGeom>
-        </p:spPr>
-      </p:pic>
-      <p:sp>
-        <p:nvSpPr>
-          <p:cNvPr id="9" name="Rounded Rectangle 8"/>
-          <p:cNvSpPr/>
-          <p:nvPr/>
-        </p:nvSpPr>
-        <p:spPr>
-          <a:xfrm>
-            <a:off x="8595360" y="4142232"/>
-            <a:ext cx="2926080" cy="384048"/>
-          </a:xfrm>
-          <a:prstGeom prst="roundRect">
-            <a:avLst/>
-          </a:prstGeom>
-          <a:solidFill>
-            <a:srgbClr val="065F46"/>
-          </a:solidFill>
-          <a:ln w="19050">
-            <a:solidFill>
-              <a:srgbClr val="34D399"/>
-            </a:solidFill>
-          </a:ln>
-        </p:spPr>
-        <p:style>
-          <a:lnRef idx="1">
-            <a:schemeClr val="accent1"/>
-          </a:lnRef>
-          <a:fillRef idx="3">
-            <a:schemeClr val="accent1"/>
-          </a:fillRef>
-          <a:effectRef idx="2">
-            <a:schemeClr val="accent1"/>
-          </a:effectRef>
-          <a:fontRef idx="minor">
-            <a:schemeClr val="lt1"/>
-          </a:fontRef>
-        </p:style>
-        <p:txBody>
-          <a:bodyPr rtlCol="0" anchor="ctr"/>
-          <a:lstStyle/>
-          <a:p>
-            <a:pPr algn="ctr">
-              <a:defRPr sz="1100" b="1">
-                <a:solidFill>
-                  <a:srgbClr val="FFFFFF"/>
-                </a:solidFill>
-                <a:latin typeface="Arial"/>
-              </a:defRPr>
-            </a:pPr>
-            <a:r>
-              <a:t>🟢 AVAILABLE IN 30 DAYS</a:t>
-            </a:r>
-          </a:p>
-        </p:txBody>
-      </p:sp>
-      <p:sp>
-        <p:nvSpPr>
-          <p:cNvPr id="10" name="TextBox 9"/>
+      <p:sp>
+        <p:nvSpPr>
+          <p:cNvPr id="8" name="TextBox 7"/>
           <p:cNvSpPr txBox="1"/>
           <p:nvPr/>
         </p:nvSpPr>
         <p:spPr>
           <a:xfrm>
-            <a:off x="731520" y="5577840"/>
-            <a:ext cx="10789920" cy="548640"/>
+            <a:off x="731520" y="5394960"/>
+            <a:ext cx="10515600" cy="731520"/>
           </a:xfrm>
           <a:prstGeom prst="rect">
             <a:avLst/>

</xml_diff>